<commit_message>
Lavra Cacau: incorpora a revisão do Lucas (consumidor, concorrentes, canais, crise)
Co-Authored-By: Claude Opus 5.5 <noreply@anthropic.com>
</commit_message>
<xml_diff>
--- a/lavra/Lavra-Cacau-Apresentacao-AUTH.pptx
+++ b/lavra/Lavra-Cacau-Apresentacao-AUTH.pptx
@@ -115,26 +115,26 @@
   <p:extLst>
     <p:ext uri="{521415D9-36F7-43E2-AB2F-B90AF26B5E84}">
       <p14:sectionLst xmlns:p14="http://schemas.microsoft.com/office/powerpoint/2010/main">
-        <p14:section name="Abertura" id="{cdea86f0-555a-fb13-a86f-83e7feb0be34}">
+        <p14:section name="Abertura" id="{43207239-33ed-b24f-a5fd-a6139bb02bee}">
           <p14:sldIdLst>
             <p14:sldId id="256"/>
             <p14:sldId id="257"/>
           </p14:sldIdLst>
         </p14:section>
-        <p14:section name="Marca e mercado" id="{1bc8a6a8-e8d2-648d-c638-8796ad294576}">
+        <p14:section name="Marca e mercado" id="{1a7bb649-03e3-957c-eb5d-980676deefaf}">
           <p14:sldIdLst>
             <p14:sldId id="258"/>
             <p14:sldId id="259"/>
           </p14:sldIdLst>
         </p14:section>
-        <p14:section name="Execução" id="{9bfd16dd-1343-a2d1-ffb5-51416ed59eea}">
+        <p14:section name="Execução" id="{b727fb6f-d204-2b00-ac21-1e5f1b1fc867}">
           <p14:sldIdLst>
             <p14:sldId id="260"/>
             <p14:sldId id="261"/>
             <p14:sldId id="262"/>
           </p14:sldIdLst>
         </p14:section>
-        <p14:section name="Crise e fechamento" id="{12b93c3c-a414-49cb-b05e-bbbd0eae093d}">
+        <p14:section name="Crise e fechamento" id="{7559d466-7746-3f2f-00b8-4adde1bba43b}">
           <p14:sldIdLst>
             <p14:sldId id="263"/>
             <p14:sldId id="264"/>
@@ -632,7 +632,7 @@
           <a:p>
             <a:r>
               <a:rPr lang="en-US" dirty="0"/>
-              <a:t>≈ 45 s. A ChocoArgo nasce de três fatos. Linhares responde por cerca de 70% do cacau do Espírito Santo. O P&amp;D da Argo Menthor tem uma variedade de cacau própria, de alta qualidade e resistente à vassoura-de-bruxa. E o board deixou claro: o sucesso também se mede pela renda dos pequenos produtores. O objetivo é levar o grupo para a área de alimentos, perto do consumidor, com ESG desde a origem.</a:t>
+              <a:t>≈ 45 s. A ChocoArgo nasce de três fatos. Linhares responde por cerca de 70% do cacau do Espírito Santo. O P&amp;D da Argo Menthor tem uma variedade de cacau própria, de alta qualidade e resistente à vassoura-de-bruxa. E o board deixou claro: o sucesso também se mede pela renda dos pequenos produtores. O objetivo é transformar os princípios ESG da holding em valor de produto e vantagem competitiva, com crescimento rentável para o grupo e sem usar a sustentabilidade só como argumento de campanha.</a:t>
             </a:r>
             <a:endParaRPr lang="en-US" dirty="0"/>
           </a:p>
@@ -808,7 +808,7 @@
           <a:p>
             <a:r>
               <a:rPr lang="en-US" dirty="0"/>
-              <a:t>≈ 50 s. Nosso consumidor tem de 28 a 50 anos, é das classes A e B, toma café especial, lê rótulos e desconfia de discurso verde sem dados. Para ele, pagar mais faz sentido quando sabe para onde vai o dinheiro. Por isso a Lavra Cacau é premium acessível. Disputamos espaço com Kopenhagen, Dengo e Lindt. Não competimos por preço: mostramos o que eles não mostram, o produtor, o lote e quanto do preço volta para o campo.</a:t>
+              <a:t>≈ 50 s. Nosso consumidor tem de 28 a 50 anos, é das classes A e B, toma café especial, lê rótulos e desconfia de discurso verde sem dados. No exterior, miramos Uruguai, Argentina e Chile. Esse público paga mais quando sabe para onde vai o dinheiro, e preço baixo sugere qualidade inferior: por isso a Lavra Cacau é premium, com preço alinhado aos concorrentes. Disputamos espaço com Nugali, Dengo e AMMA, que também falam de origem e sustentabilidade. Não competimos por preço: mostramos o que eles não mostram, o produtor, o lote e quanto do preço volta para o campo.</a:t>
             </a:r>
             <a:endParaRPr lang="en-US" dirty="0"/>
           </a:p>
@@ -984,7 +984,7 @@
           <a:p>
             <a:r>
               <a:rPr lang="en-US" dirty="0"/>
-              <a:t>≈ 50 s. Vamos vender onde o público já está: empórios, cafeterias especiais e nosso e-commerce, com um display que leva ao QR dos produtores; e lojas de aeroporto em Vitória e Guarulhos, vitrine de presente e teste para a exportação. Na comunicação, a série “Quem plantou?” no Instagram mostra o produtor real de cada lote, e as degustações nos pontos de venda apresentam a família por trás da barra.</a:t>
+              <a:t>≈ 50 s. A ChocoArgo já vende em lojas próprias e no e-commerce; as nossas lojas-conceito ficam em São Paulo e em Vitória. Somamos dois pontos onde o público já está: empórios e cafeterias especiais, com um display que leva ao QR dos produtores, e lojas de aeroporto em Vitória e Guarulhos, com totem em português e espanhol, teste para a exportação ao Uruguai, à Argentina e ao Chile. Na comunicação, a série “Quem plantou?” no Instagram mostra o produtor real de cada lote, e as degustações nos pontos de venda apresentam a família por trás da barra.</a:t>
             </a:r>
             <a:endParaRPr lang="en-US" dirty="0"/>
           </a:p>
@@ -1072,7 +1072,7 @@
           <a:p>
             <a:r>
               <a:rPr lang="en-US" dirty="0"/>
-              <a:t>≈ 50 s. O plano tem quatro fases em quinze meses. Primeiro preparar a cadeia: auditar todos os fornecedores, montar o programa de produtores com prêmio de preço e registrar a marca. Depois desenvolver os produtos e a plataforma de rastreabilidade. No mês seis, lançar em empórios, cafeterias e e-commerce, com a série “Quem plantou?”. A partir do mês nove, os aeroportos. A regra é simples: nenhuma barra chega à loja antes de 100% dos fornecedores auditados.</a:t>
+              <a:t>≈ 50 s. O plano tem quatro fases em quinze meses. Primeiro preparar a cadeia: auditar todos os fornecedores, montar o programa de produtores com prêmio de preço e registrar a marca. Depois desenvolver os produtos e a plataforma de rastreabilidade. No mês seis, lançar no e-commerce, em empórios e cafeterias, com a série “Quem plantou?”. A partir do mês oito, as lojas-conceito em São Paulo e Vitória e, depois, os aeroportos. A regra é simples: nenhuma barra chega à loja antes de 100% dos fornecedores auditados.</a:t>
             </a:r>
             <a:endParaRPr lang="en-US" dirty="0"/>
           </a:p>
@@ -1160,7 +1160,7 @@
           <a:p>
             <a:r>
               <a:rPr lang="en-US" dirty="0"/>
-              <a:t>≈ 70 s. A crise tem duas frentes. No ataque hacker, a ação 1 é externa: em 24 horas, remover o vídeo adulterado e publicar a versão verdadeira nos canais verificados. A ação 2 é interna: perícia, autenticação em dois fatores, comunicado da presidência e treinamento. Na denúncia de trabalho infantil, a ação 3 abre a cadeia: auditoria de 100% dos fornecedores, resultados no QR das barras e compromisso com o Ministério Público do Trabalho. A ação 4 não se limita a romper contratos: acompanha as crianças na escola, cria código de conduta e canal de denúncia. Princípios: falar primeiro, assumir a parte da empresa e provar o que mudou.</a:t>
+              <a:t>≈ 70 s. A crise tem duas frentes. No ataque hacker, a ação 1 é externa: em 24 horas, remover o vídeo falso e publicar o original nos canais oficiais. A ação 2 é interna: investigar a falha, ativar dois fatores, apoiar o coordenador e treinar a equipe. Na denúncia de trabalho infantil, a ação 3 abre a cadeia: auditoria de 100% dos fornecedores, resultados no QR das barras compromisso com o Ministério Público do Trabalho e relatórios trimestrais. A ação 4 protege as crianças: acompanhamento com o Conselho Tutelar, matrícula e transporte escolar, além de código de conduta e canal de denúncia. Responder, corrigir e prevenir.</a:t>
             </a:r>
             <a:endParaRPr lang="en-US" dirty="0"/>
           </a:p>
@@ -1248,7 +1248,7 @@
           <a:p>
             <a:r>
               <a:rPr lang="en-US" dirty="0"/>
-              <a:t>≈ 25 s. Para fechar: a Lavra Cacau transforma o ponto fraco da ChocoArgo em proposta de valor. Cada barra tem autor, o QR code comprova e o preço premium acessível remunera os produtores com escala. Do produtor à barra, sem segredo. Obrigado, ficamos à disposição para perguntas.</a:t>
+              <a:t>≈ 25 s. Para fechar: a Lavra Cacau transforma o ponto fraco da ChocoArgo em proposta de valor. Cada barra tem autor, o QR code comprova e o preço premium remunera os produtores. Do produtor à barra, sem segredo. Obrigado, ficamos à disposição para perguntas.</a:t>
             </a:r>
             <a:endParaRPr lang="en-US" dirty="0"/>
           </a:p>
@@ -2942,7 +2942,7 @@
                 <a:ea typeface="Arial" pitchFamily="34" charset="-122"/>
                 <a:cs typeface="Arial" pitchFamily="34" charset="-120"/>
               </a:rPr>
-              <a:t>Objetivo: levar a Argo Menthor para alimentos e para perto do consumidor, com ESG desde a origem, no Brasil e na exportação.</a:t>
+              <a:t>Objetivo: transformar o ESG da holding em valor de produto, com crescimento rentável e mais renda para os pequenos produtores.</a:t>
             </a:r>
             <a:endParaRPr lang="en-US" sz="1600" dirty="0"/>
           </a:p>
@@ -3729,7 +3729,7 @@
                 <a:ea typeface="Arial" pitchFamily="34" charset="-122"/>
                 <a:cs typeface="Arial" pitchFamily="34" charset="-120"/>
               </a:rPr>
-              <a:t>Toma café especial, lê rótulos, dá chocolate de presente</a:t>
+              <a:t>Exterior: Uruguai, Argentina e Chile</a:t>
             </a:r>
             <a:endParaRPr lang="en-US" sz="1600" dirty="0"/>
           </a:p>
@@ -3789,7 +3789,7 @@
                 <a:ea typeface="Arial" pitchFamily="34" charset="-122"/>
                 <a:cs typeface="Arial" pitchFamily="34" charset="-120"/>
               </a:rPr>
-              <a:t>Premium acessível · R$ 26 a R$ 32 (80 g)</a:t>
+              <a:t>Premium · R$ 26 a R$ 32 (80 g)</a:t>
             </a:r>
             <a:endParaRPr lang="en-US" sz="1400" dirty="0"/>
           </a:p>
@@ -3899,7 +3899,7 @@
                 <a:ea typeface="Arial" pitchFamily="34" charset="-122"/>
                 <a:cs typeface="Arial" pitchFamily="34" charset="-120"/>
               </a:rPr>
-              <a:t>Kopenhagen</a:t>
+              <a:t>Nugali</a:t>
             </a:r>
             <a:endParaRPr lang="en-US" sz="1600" dirty="0"/>
           </a:p>
@@ -3938,7 +3938,7 @@
                 <a:ea typeface="Arial" pitchFamily="34" charset="-122"/>
                 <a:cs typeface="Arial" pitchFamily="34" charset="-120"/>
               </a:rPr>
-              <a:t>tradição e presente</a:t>
+              <a:t>pioneira do bean-to-bar</a:t>
             </a:r>
             <a:endParaRPr lang="en-US" sz="1400" dirty="0"/>
           </a:p>
@@ -3955,7 +3955,7 @@
                 <a:ea typeface="Arial" pitchFamily="34" charset="-122"/>
                 <a:cs typeface="Arial" pitchFamily="34" charset="-120"/>
               </a:rPr>
-              <a:t>origem única e produtor nomeado</a:t>
+              <a:t>produtor comprovado por lote</a:t>
             </a:r>
             <a:endParaRPr lang="en-US" sz="1400" dirty="0"/>
           </a:p>
@@ -4153,7 +4153,7 @@
                 <a:ea typeface="Arial" pitchFamily="34" charset="-122"/>
                 <a:cs typeface="Arial" pitchFamily="34" charset="-120"/>
               </a:rPr>
-              <a:t>Lindt Excellence</a:t>
+              <a:t>AMMA</a:t>
             </a:r>
             <a:endParaRPr lang="en-US" sz="1600" dirty="0"/>
           </a:p>
@@ -4192,7 +4192,7 @@
                 <a:ea typeface="Arial" pitchFamily="34" charset="-122"/>
                 <a:cs typeface="Arial" pitchFamily="34" charset="-120"/>
               </a:rPr>
-              <a:t>importada, gôndola 70%</a:t>
+              <a:t>orgânica e agroflorestal</a:t>
             </a:r>
             <a:endParaRPr lang="en-US" sz="1400" dirty="0"/>
           </a:p>
@@ -4209,7 +4209,7 @@
                 <a:ea typeface="Arial" pitchFamily="34" charset="-122"/>
                 <a:cs typeface="Arial" pitchFamily="34" charset="-120"/>
               </a:rPr>
-              <a:t>origem brasileira e história do produtor</a:t>
+              <a:t>renda publicada por família</a:t>
             </a:r>
             <a:endParaRPr lang="en-US" sz="1400" dirty="0"/>
           </a:p>
@@ -4342,8 +4342,8 @@
         </p:blipFill>
         <p:spPr>
           <a:xfrm>
-            <a:off x="551633" y="1188720"/>
-            <a:ext cx="2554334" cy="2057400"/>
+            <a:off x="548640" y="1188720"/>
+            <a:ext cx="2560320" cy="1936533"/>
           </a:xfrm>
           <a:prstGeom prst="rect">
             <a:avLst/>
@@ -4501,7 +4501,7 @@
         <p:spPr>
           <a:xfrm>
             <a:off x="3291840" y="1188720"/>
-            <a:ext cx="2560320" cy="2027308"/>
+            <a:ext cx="2560320" cy="1936533"/>
           </a:xfrm>
           <a:prstGeom prst="rect">
             <a:avLst/>
@@ -4659,7 +4659,7 @@
         <p:spPr>
           <a:xfrm>
             <a:off x="6035040" y="1188720"/>
-            <a:ext cx="2560320" cy="1517571"/>
+            <a:ext cx="2560320" cy="1533864"/>
           </a:xfrm>
           <a:prstGeom prst="rect">
             <a:avLst/>
@@ -4911,9 +4911,62 @@
           </a:p>
         </p:txBody>
       </p:sp>
+      <p:sp>
+        <p:nvSpPr>
+          <p:cNvPr id="3" name="Text 1"/>
+          <p:cNvSpPr txBox="1"/>
+          <p:nvPr/>
+        </p:nvSpPr>
+        <p:spPr>
+          <a:xfrm>
+            <a:off x="548640" y="1097280"/>
+            <a:ext cx="8046720" cy="320040"/>
+          </a:xfrm>
+          <a:prstGeom prst="rect">
+            <a:avLst/>
+          </a:prstGeom>
+          <a:noFill/>
+          <a:ln/>
+        </p:spPr>
+        <p:txBody>
+          <a:bodyPr wrap="square" lIns="0" tIns="0" rIns="0" bIns="0" rtlCol="0" anchor="t"/>
+          <a:lstStyle/>
+          <a:p>
+            <a:pPr indent="0" marL="0">
+              <a:buNone/>
+            </a:pPr>
+            <a:r>
+              <a:rPr lang="en-US" sz="1400" b="1" dirty="0">
+                <a:solidFill>
+                  <a:srgbClr val="A4492A"/>
+                </a:solidFill>
+                <a:latin typeface="Arial" pitchFamily="34" charset="0"/>
+                <a:ea typeface="Arial" pitchFamily="34" charset="-122"/>
+                <a:cs typeface="Arial" pitchFamily="34" charset="-120"/>
+              </a:rPr>
+              <a:t>Canais da ChocoArgo: </a:t>
+            </a:r>
+            <a:pPr indent="0" marL="0">
+              <a:buNone/>
+            </a:pPr>
+            <a:r>
+              <a:rPr lang="en-US" sz="1400" dirty="0">
+                <a:solidFill>
+                  <a:srgbClr val="2A1A14"/>
+                </a:solidFill>
+                <a:latin typeface="Arial" pitchFamily="34" charset="0"/>
+                <a:ea typeface="Arial" pitchFamily="34" charset="-122"/>
+                <a:cs typeface="Arial" pitchFamily="34" charset="-120"/>
+              </a:rPr>
+              <a:t>lojas próprias (São Paulo e Vitória) e e-commerce. Somamos:</a:t>
+            </a:r>
+            <a:endParaRPr lang="en-US" sz="1400" dirty="0"/>
+          </a:p>
+        </p:txBody>
+      </p:sp>
       <p:pic>
         <p:nvPicPr>
-          <p:cNvPr id="3" name="Empórios e cafeterias, com e‑commerce" descr="Empórios e cafeterias, com e‑commerce">    </p:cNvPr>
+          <p:cNvPr id="4" name="Empórios e cafeterias especiais" descr="Empórios e cafeterias especiais">    </p:cNvPr>
           <p:cNvPicPr>
             <a:picLocks noChangeAspect="1"/>
           </p:cNvPicPr>
@@ -4927,8 +4980,8 @@
         </p:blipFill>
         <p:spPr>
           <a:xfrm>
-            <a:off x="548640" y="1188720"/>
-            <a:ext cx="1874520" cy="1630017"/>
+            <a:off x="567279" y="1508760"/>
+            <a:ext cx="1837243" cy="1874520"/>
           </a:xfrm>
           <a:prstGeom prst="rect">
             <a:avLst/>
@@ -4937,13 +4990,13 @@
       </p:pic>
       <p:sp>
         <p:nvSpPr>
-          <p:cNvPr id="4" name="Text 1"/>
-          <p:cNvSpPr txBox="1"/>
-          <p:nvPr/>
-        </p:nvSpPr>
-        <p:spPr>
-          <a:xfrm>
-            <a:off x="548640" y="3429000"/>
+          <p:cNvPr id="5" name="Text 2"/>
+          <p:cNvSpPr txBox="1"/>
+          <p:nvPr/>
+        </p:nvSpPr>
+        <p:spPr>
+          <a:xfrm>
+            <a:off x="548640" y="3520440"/>
             <a:ext cx="1874520" cy="237744"/>
           </a:xfrm>
           <a:prstGeom prst="rect">
@@ -4976,14 +5029,14 @@
       </p:sp>
       <p:sp>
         <p:nvSpPr>
-          <p:cNvPr id="5" name="Text 2"/>
-          <p:cNvSpPr txBox="1"/>
-          <p:nvPr/>
-        </p:nvSpPr>
-        <p:spPr>
-          <a:xfrm>
-            <a:off x="548640" y="3703320"/>
-            <a:ext cx="1874520" cy="777240"/>
+          <p:cNvPr id="6" name="Text 3"/>
+          <p:cNvSpPr txBox="1"/>
+          <p:nvPr/>
+        </p:nvSpPr>
+        <p:spPr>
+          <a:xfrm>
+            <a:off x="548640" y="3776472"/>
+            <a:ext cx="1874520" cy="731520"/>
           </a:xfrm>
           <a:prstGeom prst="rect">
             <a:avLst/>
@@ -5007,7 +5060,7 @@
                 <a:ea typeface="Arial" pitchFamily="34" charset="-122"/>
                 <a:cs typeface="Arial" pitchFamily="34" charset="-120"/>
               </a:rPr>
-              <a:t>Empórios e cafeterias, com e‑commerce</a:t>
+              <a:t>Empórios e cafeterias especiais</a:t>
             </a:r>
             <a:endParaRPr lang="en-US" sz="1600" dirty="0"/>
           </a:p>
@@ -5015,7 +5068,7 @@
       </p:sp>
       <p:pic>
         <p:nvPicPr>
-          <p:cNvPr id="6" name="Aeroportos de Vitória e Guarulhos" descr="Aeroportos de Vitória e Guarulhos">    </p:cNvPr>
+          <p:cNvPr id="7" name="Aeroportos de Vitória e Guarulhos" descr="Aeroportos de Vitória e Guarulhos">    </p:cNvPr>
           <p:cNvPicPr>
             <a:picLocks noChangeAspect="1"/>
           </p:cNvPicPr>
@@ -5029,8 +5082,8 @@
         </p:blipFill>
         <p:spPr>
           <a:xfrm>
-            <a:off x="3023256" y="1188720"/>
-            <a:ext cx="1040088" cy="2103120"/>
+            <a:off x="3100705" y="1508760"/>
+            <a:ext cx="885190" cy="1874520"/>
           </a:xfrm>
           <a:prstGeom prst="rect">
             <a:avLst/>
@@ -5039,13 +5092,13 @@
       </p:pic>
       <p:sp>
         <p:nvSpPr>
-          <p:cNvPr id="7" name="Text 3"/>
-          <p:cNvSpPr txBox="1"/>
-          <p:nvPr/>
-        </p:nvSpPr>
-        <p:spPr>
-          <a:xfrm>
-            <a:off x="2606040" y="3429000"/>
+          <p:cNvPr id="8" name="Text 4"/>
+          <p:cNvSpPr txBox="1"/>
+          <p:nvPr/>
+        </p:nvSpPr>
+        <p:spPr>
+          <a:xfrm>
+            <a:off x="2606040" y="3520440"/>
             <a:ext cx="1874520" cy="237744"/>
           </a:xfrm>
           <a:prstGeom prst="rect">
@@ -5078,14 +5131,14 @@
       </p:sp>
       <p:sp>
         <p:nvSpPr>
-          <p:cNvPr id="8" name="Text 4"/>
-          <p:cNvSpPr txBox="1"/>
-          <p:nvPr/>
-        </p:nvSpPr>
-        <p:spPr>
-          <a:xfrm>
-            <a:off x="2606040" y="3703320"/>
-            <a:ext cx="1874520" cy="777240"/>
+          <p:cNvPr id="9" name="Text 5"/>
+          <p:cNvSpPr txBox="1"/>
+          <p:nvPr/>
+        </p:nvSpPr>
+        <p:spPr>
+          <a:xfrm>
+            <a:off x="2606040" y="3776472"/>
+            <a:ext cx="1874520" cy="731520"/>
           </a:xfrm>
           <a:prstGeom prst="rect">
             <a:avLst/>
@@ -5117,7 +5170,7 @@
       </p:sp>
       <p:pic>
         <p:nvPicPr>
-          <p:cNvPr id="9" name="Série “Quem plantou?” no Instagram" descr="Série “Quem plantou?” no Instagram">    </p:cNvPr>
+          <p:cNvPr id="10" name="Série “Quem plantou?” no Instagram" descr="Série “Quem plantou?” no Instagram">    </p:cNvPr>
           <p:cNvPicPr>
             <a:picLocks noChangeAspect="1"/>
           </p:cNvPicPr>
@@ -5131,7 +5184,7 @@
         </p:blipFill>
         <p:spPr>
           <a:xfrm>
-            <a:off x="4663440" y="1188720"/>
+            <a:off x="4663440" y="1508760"/>
             <a:ext cx="1874520" cy="1874520"/>
           </a:xfrm>
           <a:prstGeom prst="rect">
@@ -5141,13 +5194,13 @@
       </p:pic>
       <p:sp>
         <p:nvSpPr>
-          <p:cNvPr id="10" name="Text 5"/>
-          <p:cNvSpPr txBox="1"/>
-          <p:nvPr/>
-        </p:nvSpPr>
-        <p:spPr>
-          <a:xfrm>
-            <a:off x="4663440" y="3429000"/>
+          <p:cNvPr id="11" name="Text 6"/>
+          <p:cNvSpPr txBox="1"/>
+          <p:nvPr/>
+        </p:nvSpPr>
+        <p:spPr>
+          <a:xfrm>
+            <a:off x="4663440" y="3520440"/>
             <a:ext cx="1874520" cy="237744"/>
           </a:xfrm>
           <a:prstGeom prst="rect">
@@ -5180,14 +5233,14 @@
       </p:sp>
       <p:sp>
         <p:nvSpPr>
-          <p:cNvPr id="11" name="Text 6"/>
-          <p:cNvSpPr txBox="1"/>
-          <p:nvPr/>
-        </p:nvSpPr>
-        <p:spPr>
-          <a:xfrm>
-            <a:off x="4663440" y="3703320"/>
-            <a:ext cx="1874520" cy="777240"/>
+          <p:cNvPr id="12" name="Text 7"/>
+          <p:cNvSpPr txBox="1"/>
+          <p:nvPr/>
+        </p:nvSpPr>
+        <p:spPr>
+          <a:xfrm>
+            <a:off x="4663440" y="3776472"/>
+            <a:ext cx="1874520" cy="731520"/>
           </a:xfrm>
           <a:prstGeom prst="rect">
             <a:avLst/>
@@ -5219,7 +5272,7 @@
       </p:sp>
       <p:pic>
         <p:nvPicPr>
-          <p:cNvPr id="12" name="Degustação com o cartão do produtor" descr="Degustação com o cartão do produtor">    </p:cNvPr>
+          <p:cNvPr id="13" name="Degustação com o cartão do produtor" descr="Degustação com o cartão do produtor">    </p:cNvPr>
           <p:cNvPicPr>
             <a:picLocks noChangeAspect="1"/>
           </p:cNvPicPr>
@@ -5233,8 +5286,8 @@
         </p:blipFill>
         <p:spPr>
           <a:xfrm>
-            <a:off x="6720840" y="1188720"/>
-            <a:ext cx="1874520" cy="1837030"/>
+            <a:off x="6765471" y="1508760"/>
+            <a:ext cx="1785257" cy="1874520"/>
           </a:xfrm>
           <a:prstGeom prst="rect">
             <a:avLst/>
@@ -5243,13 +5296,13 @@
       </p:pic>
       <p:sp>
         <p:nvSpPr>
-          <p:cNvPr id="13" name="Text 7"/>
-          <p:cNvSpPr txBox="1"/>
-          <p:nvPr/>
-        </p:nvSpPr>
-        <p:spPr>
-          <a:xfrm>
-            <a:off x="6720840" y="3429000"/>
+          <p:cNvPr id="14" name="Text 8"/>
+          <p:cNvSpPr txBox="1"/>
+          <p:nvPr/>
+        </p:nvSpPr>
+        <p:spPr>
+          <a:xfrm>
+            <a:off x="6720840" y="3520440"/>
             <a:ext cx="1874520" cy="237744"/>
           </a:xfrm>
           <a:prstGeom prst="rect">
@@ -5282,14 +5335,14 @@
       </p:sp>
       <p:sp>
         <p:nvSpPr>
-          <p:cNvPr id="14" name="Text 8"/>
-          <p:cNvSpPr txBox="1"/>
-          <p:nvPr/>
-        </p:nvSpPr>
-        <p:spPr>
-          <a:xfrm>
-            <a:off x="6720840" y="3703320"/>
-            <a:ext cx="1874520" cy="777240"/>
+          <p:cNvPr id="15" name="Text 9"/>
+          <p:cNvSpPr txBox="1"/>
+          <p:nvPr/>
+        </p:nvSpPr>
+        <p:spPr>
+          <a:xfrm>
+            <a:off x="6720840" y="3776472"/>
+            <a:ext cx="1874520" cy="731520"/>
           </a:xfrm>
           <a:prstGeom prst="rect">
             <a:avLst/>
@@ -5424,7 +5477,7 @@
                 <a:ea typeface="Times New Roman" pitchFamily="34" charset="-122"/>
                 <a:cs typeface="Times New Roman" pitchFamily="34" charset="-120"/>
               </a:rPr>
-              <a:t>Plano de ação: cadeia limpa antes da prateleira</a:t>
+              <a:t>Execução: cadeia limpa antes da prateleira</a:t>
             </a:r>
             <a:endParaRPr lang="en-US" sz="3200" dirty="0"/>
           </a:p>
@@ -5873,7 +5926,7 @@
                 <a:ea typeface="Arial" pitchFamily="34" charset="-122"/>
                 <a:cs typeface="Arial" pitchFamily="34" charset="-120"/>
               </a:rPr>
-              <a:t>Empórios, cafeterias e e-commerce; “Quem plantou?” e degustações</a:t>
+              <a:t>E-commerce, empórios e cafeterias; “Quem plantou?” e degustações</a:t>
             </a:r>
             <a:endParaRPr lang="en-US" sz="1400" dirty="0"/>
           </a:p>
@@ -5937,7 +5990,7 @@
                 <a:ea typeface="Courier New" pitchFamily="34" charset="-122"/>
                 <a:cs typeface="Courier New" pitchFamily="34" charset="-120"/>
               </a:rPr>
-              <a:t>Meses 9–15</a:t>
+              <a:t>Meses 8–15</a:t>
             </a:r>
             <a:endParaRPr lang="en-US" sz="1200" dirty="0"/>
           </a:p>
@@ -6015,7 +6068,7 @@
                 <a:ea typeface="Arial" pitchFamily="34" charset="-122"/>
                 <a:cs typeface="Arial" pitchFamily="34" charset="-120"/>
               </a:rPr>
-              <a:t>Lojas de aeroporto em Vitória e Guarulhos; preparar a exportação</a:t>
+              <a:t>Lojas-conceito em São Paulo e Vitória e aeroportos; preparar a exportação</a:t>
             </a:r>
             <a:endParaRPr lang="en-US" sz="1400" dirty="0"/>
           </a:p>
@@ -6211,7 +6264,7 @@
                 <a:ea typeface="Times New Roman" pitchFamily="34" charset="-122"/>
                 <a:cs typeface="Times New Roman" pitchFamily="34" charset="-120"/>
               </a:rPr>
-              <a:t>Gestão de crise: falar primeiro, assumir, provar</a:t>
+              <a:t>Gestão de crise: responder, corrigir e prevenir</a:t>
             </a:r>
             <a:endParaRPr lang="en-US" sz="3200" dirty="0"/>
           </a:p>
@@ -6360,7 +6413,7 @@
                 <a:ea typeface="Arial" pitchFamily="34" charset="-122"/>
                 <a:cs typeface="Arial" pitchFamily="34" charset="-120"/>
               </a:rPr>
-              <a:t>Versão oficial em 24 h</a:t>
+              <a:t>Resposta pública em 24 h</a:t>
             </a:r>
             <a:endParaRPr lang="en-US" sz="1800" dirty="0"/>
           </a:p>
@@ -6399,7 +6452,7 @@
                 <a:ea typeface="Arial" pitchFamily="34" charset="-122"/>
                 <a:cs typeface="Arial" pitchFamily="34" charset="-120"/>
               </a:rPr>
-              <a:t>Externo · remoção do vídeo adulterado, nota e vídeo original nos canais verificados</a:t>
+              <a:t>Externo · remoção do vídeo falso, nota e vídeo original nos canais oficiais</a:t>
             </a:r>
             <a:endParaRPr lang="en-US" sz="1400" dirty="0"/>
           </a:p>
@@ -6509,7 +6562,7 @@
                 <a:ea typeface="Arial" pitchFamily="34" charset="-122"/>
                 <a:cs typeface="Arial" pitchFamily="34" charset="-120"/>
               </a:rPr>
-              <a:t>Casa protegida</a:t>
+              <a:t>Segurança e equipe</a:t>
             </a:r>
             <a:endParaRPr lang="en-US" sz="1800" dirty="0"/>
           </a:p>
@@ -6548,7 +6601,7 @@
                 <a:ea typeface="Arial" pitchFamily="34" charset="-122"/>
                 <a:cs typeface="Arial" pitchFamily="34" charset="-120"/>
               </a:rPr>
-              <a:t>Interno · perícia, dois fatores, comunicado da presidência e treinamento contra phishing</a:t>
+              <a:t>Interno · investigar a falha, dois fatores, apoio ao coordenador e treinamento contra phishing</a:t>
             </a:r>
             <a:endParaRPr lang="en-US" sz="1400" dirty="0"/>
           </a:p>
@@ -6736,7 +6789,7 @@
                 <a:ea typeface="Arial" pitchFamily="34" charset="-122"/>
                 <a:cs typeface="Arial" pitchFamily="34" charset="-120"/>
               </a:rPr>
-              <a:t>Externo · auditoria de 100% publicada no QR, termo com o MPT e relatório a cada 90 dias</a:t>
+              <a:t>Externo · auditoria de 100% publicada no QR, compromisso com o MPT e relatórios trimestrais</a:t>
             </a:r>
             <a:endParaRPr lang="en-US" sz="1400" dirty="0"/>
           </a:p>
@@ -6846,7 +6899,7 @@
                 <a:ea typeface="Arial" pitchFamily="34" charset="-122"/>
                 <a:cs typeface="Arial" pitchFamily="34" charset="-120"/>
               </a:rPr>
-              <a:t>Remediar, não só romper</a:t>
+              <a:t>Proteção às crianças</a:t>
             </a:r>
             <a:endParaRPr lang="en-US" sz="1800" dirty="0"/>
           </a:p>
@@ -6885,7 +6938,7 @@
                 <a:ea typeface="Arial" pitchFamily="34" charset="-122"/>
                 <a:cs typeface="Arial" pitchFamily="34" charset="-120"/>
               </a:rPr>
-              <a:t>Interno e produtores · crianças acompanhadas na escola, código de conduta e canal de denúncia</a:t>
+              <a:t>Interno · crianças acompanhadas com o Conselho Tutelar, código de conduta e canal de denúncia</a:t>
             </a:r>
             <a:endParaRPr lang="en-US" sz="1400" dirty="0"/>
           </a:p>

</xml_diff>

<commit_message>
PPT Lavra Cacau: slide 4 separa concorrentes e diferenciais
Co-Authored-By: Claude Opus 5.5 <noreply@anthropic.com>
</commit_message>
<xml_diff>
--- a/lavra/Lavra-Cacau-Apresentacao-AUTH.pptx
+++ b/lavra/Lavra-Cacau-Apresentacao-AUTH.pptx
@@ -115,26 +115,26 @@
   <p:extLst>
     <p:ext uri="{521415D9-36F7-43E2-AB2F-B90AF26B5E84}">
       <p14:sectionLst xmlns:p14="http://schemas.microsoft.com/office/powerpoint/2010/main">
-        <p14:section name="Abertura" id="{43207239-33ed-b24f-a5fd-a6139bb02bee}">
+        <p14:section name="Abertura" id="{3d5fa871-e671-f2e3-1c3d-a82e5ca07428}">
           <p14:sldIdLst>
             <p14:sldId id="256"/>
             <p14:sldId id="257"/>
           </p14:sldIdLst>
         </p14:section>
-        <p14:section name="Marca e mercado" id="{1a7bb649-03e3-957c-eb5d-980676deefaf}">
+        <p14:section name="Marca e mercado" id="{08b64442-b52d-8a52-1e61-acaf9007bb7c}">
           <p14:sldIdLst>
             <p14:sldId id="258"/>
             <p14:sldId id="259"/>
           </p14:sldIdLst>
         </p14:section>
-        <p14:section name="Execução" id="{b727fb6f-d204-2b00-ac21-1e5f1b1fc867}">
+        <p14:section name="Execução" id="{8a20f287-9eb9-9d46-143c-a5451237100f}">
           <p14:sldIdLst>
             <p14:sldId id="260"/>
             <p14:sldId id="261"/>
             <p14:sldId id="262"/>
           </p14:sldIdLst>
         </p14:section>
-        <p14:section name="Crise e fechamento" id="{7559d466-7746-3f2f-00b8-4adde1bba43b}">
+        <p14:section name="Crise e fechamento" id="{63a2b2b4-83e5-6fe2-1910-30f63732e3b9}">
           <p14:sldIdLst>
             <p14:sldId id="263"/>
             <p14:sldId id="264"/>
@@ -808,7 +808,7 @@
           <a:p>
             <a:r>
               <a:rPr lang="en-US" dirty="0"/>
-              <a:t>≈ 50 s. Nosso consumidor tem de 28 a 50 anos, é das classes A e B, toma café especial, lê rótulos e desconfia de discurso verde sem dados. No exterior, miramos Uruguai, Argentina e Chile. Esse público paga mais quando sabe para onde vai o dinheiro, e preço baixo sugere qualidade inferior: por isso a Lavra Cacau é premium, com preço alinhado aos concorrentes. Disputamos espaço com Nugali, Dengo e AMMA, que também falam de origem e sustentabilidade. Não competimos por preço: mostramos o que eles não mostram, o produtor, o lote e quanto do preço volta para o campo.</a:t>
+              <a:t>≈ 50 s. Nosso consumidor é das classes A e B, compra na faixa premium e valoriza saudabilidade, origem e sustentabilidade. O foco é o Sudeste e o Sul e, no exterior, Uruguai, Argentina e Chile. Esse público paga mais quando sabe para onde vai o dinheiro, e preço baixo sugere qualidade inferior: por isso a Lavra Cacau é premium, com preço alinhado aos concorrentes. Disputamos espaço com Nugali, Dengo e AMMA, que também falam de origem e sustentabilidade: à esquerda, o que cada uma oferece; à direita, o que só a Lavra Cacau mostra. Não competimos por preço: mostramos o produtor, o lote e quanto do preço volta para o campo.</a:t>
             </a:r>
             <a:endParaRPr lang="en-US" dirty="0"/>
           </a:p>
@@ -3609,7 +3609,7 @@
         <p:spPr>
           <a:xfrm>
             <a:off x="548640" y="1188720"/>
-            <a:ext cx="3566160" cy="3246120"/>
+            <a:ext cx="2834640" cy="3200400"/>
           </a:xfrm>
           <a:prstGeom prst="rect">
             <a:avLst/>
@@ -3640,8 +3640,8 @@
         </p:nvSpPr>
         <p:spPr>
           <a:xfrm>
-            <a:off x="822960" y="1417320"/>
-            <a:ext cx="3017520" cy="237744"/>
+            <a:off x="777240" y="1371600"/>
+            <a:ext cx="2468880" cy="237744"/>
           </a:xfrm>
           <a:prstGeom prst="rect">
             <a:avLst/>
@@ -3679,8 +3679,8 @@
         </p:nvSpPr>
         <p:spPr>
           <a:xfrm>
-            <a:off x="822960" y="1737360"/>
-            <a:ext cx="3063240" cy="1737360"/>
+            <a:off x="777240" y="1691640"/>
+            <a:ext cx="2468880" cy="2011680"/>
           </a:xfrm>
           <a:prstGeom prst="rect">
             <a:avLst/>
@@ -3694,78 +3694,131 @@
           <a:p>
             <a:pPr marL="342900" indent="-342900">
               <a:spcAft>
-                <a:spcPts val="600"/>
+                <a:spcPts val="800"/>
               </a:spcAft>
               <a:buSzPct val="100000"/>
               <a:buChar char="•"/>
             </a:pPr>
             <a:r>
-              <a:rPr lang="en-US" sz="1600" dirty="0">
+              <a:rPr lang="en-US" sz="1800" dirty="0">
                 <a:solidFill>
                   <a:schemeClr val="bg1"/>
+                </a:solidFill>
+                <a:latin typeface="Times New Roman" pitchFamily="34" charset="0"/>
+                <a:ea typeface="Times New Roman" pitchFamily="34" charset="-122"/>
+                <a:cs typeface="Times New Roman" pitchFamily="34" charset="-120"/>
+              </a:rPr>
+              <a:t>Classe A/B</a:t>
+            </a:r>
+            <a:endParaRPr lang="en-US" sz="1800" dirty="0"/>
+          </a:p>
+          <a:p>
+            <a:pPr marL="342900" indent="-342900">
+              <a:spcAft>
+                <a:spcPts val="800"/>
+              </a:spcAft>
+              <a:buSzPct val="100000"/>
+              <a:buChar char="•"/>
+            </a:pPr>
+            <a:r>
+              <a:rPr lang="en-US" sz="1800" dirty="0">
+                <a:solidFill>
+                  <a:schemeClr val="bg1"/>
+                </a:solidFill>
+                <a:latin typeface="Times New Roman" pitchFamily="34" charset="0"/>
+                <a:ea typeface="Times New Roman" pitchFamily="34" charset="-122"/>
+                <a:cs typeface="Times New Roman" pitchFamily="34" charset="-120"/>
+              </a:rPr>
+              <a:t>Faixa premium</a:t>
+            </a:r>
+            <a:endParaRPr lang="en-US" sz="1800" dirty="0"/>
+          </a:p>
+          <a:p>
+            <a:pPr marL="342900" indent="-342900">
+              <a:spcAft>
+                <a:spcPts val="800"/>
+              </a:spcAft>
+              <a:buSzPct val="100000"/>
+              <a:buChar char="•"/>
+            </a:pPr>
+            <a:r>
+              <a:rPr lang="en-US" sz="1800" dirty="0">
+                <a:solidFill>
+                  <a:schemeClr val="bg1"/>
+                </a:solidFill>
+                <a:latin typeface="Times New Roman" pitchFamily="34" charset="0"/>
+                <a:ea typeface="Times New Roman" pitchFamily="34" charset="-122"/>
+                <a:cs typeface="Times New Roman" pitchFamily="34" charset="-120"/>
+              </a:rPr>
+              <a:t>Saudabilidade, origem e sustentabilidade</a:t>
+            </a:r>
+            <a:endParaRPr lang="en-US" sz="1800" dirty="0"/>
+          </a:p>
+        </p:txBody>
+      </p:sp>
+      <p:sp>
+        <p:nvSpPr>
+          <p:cNvPr id="6" name="Text 4"/>
+          <p:cNvSpPr txBox="1"/>
+          <p:nvPr/>
+        </p:nvSpPr>
+        <p:spPr>
+          <a:xfrm>
+            <a:off x="777240" y="3611880"/>
+            <a:ext cx="2468880" cy="640080"/>
+          </a:xfrm>
+          <a:prstGeom prst="rect">
+            <a:avLst/>
+          </a:prstGeom>
+          <a:noFill/>
+          <a:ln/>
+        </p:spPr>
+        <p:txBody>
+          <a:bodyPr wrap="square" lIns="0" tIns="0" rIns="0" bIns="0" rtlCol="0" anchor="b"/>
+          <a:lstStyle/>
+          <a:p>
+            <a:pPr indent="0" marL="0">
+              <a:buNone/>
+            </a:pPr>
+            <a:r>
+              <a:rPr lang="en-US" sz="1400" b="1" dirty="0">
+                <a:solidFill>
+                  <a:schemeClr val="accent6"/>
                 </a:solidFill>
                 <a:latin typeface="Arial" pitchFamily="34" charset="0"/>
                 <a:ea typeface="Arial" pitchFamily="34" charset="-122"/>
                 <a:cs typeface="Arial" pitchFamily="34" charset="-120"/>
               </a:rPr>
-              <a:t>28 a 50 anos, classes A e B, capitais do Sudeste e do Sul</a:t>
-            </a:r>
-            <a:endParaRPr lang="en-US" sz="1600" dirty="0"/>
-          </a:p>
-          <a:p>
-            <a:pPr marL="342900" indent="-342900">
-              <a:spcAft>
-                <a:spcPts val="600"/>
-              </a:spcAft>
-              <a:buSzPct val="100000"/>
-              <a:buChar char="•"/>
-            </a:pPr>
-            <a:r>
-              <a:rPr lang="en-US" sz="1600" dirty="0">
-                <a:solidFill>
-                  <a:schemeClr val="bg1"/>
+              <a:t>Foco: </a:t>
+            </a:r>
+            <a:pPr indent="0" marL="0">
+              <a:buNone/>
+            </a:pPr>
+            <a:r>
+              <a:rPr lang="en-US" sz="1400" dirty="0">
+                <a:solidFill>
+                  <a:schemeClr val="accent2"/>
                 </a:solidFill>
                 <a:latin typeface="Arial" pitchFamily="34" charset="0"/>
                 <a:ea typeface="Arial" pitchFamily="34" charset="-122"/>
                 <a:cs typeface="Arial" pitchFamily="34" charset="-120"/>
               </a:rPr>
-              <a:t>Exterior: Uruguai, Argentina e Chile</a:t>
-            </a:r>
-            <a:endParaRPr lang="en-US" sz="1600" dirty="0"/>
-          </a:p>
-          <a:p>
-            <a:pPr marL="342900" indent="-342900">
-              <a:spcAft>
-                <a:spcPts val="600"/>
-              </a:spcAft>
-              <a:buSzPct val="100000"/>
-              <a:buChar char="•"/>
-            </a:pPr>
-            <a:r>
-              <a:rPr lang="en-US" sz="1600" dirty="0">
-                <a:solidFill>
-                  <a:schemeClr val="bg1"/>
-                </a:solidFill>
-                <a:latin typeface="Arial" pitchFamily="34" charset="0"/>
-                <a:ea typeface="Arial" pitchFamily="34" charset="-122"/>
-                <a:cs typeface="Arial" pitchFamily="34" charset="-120"/>
-              </a:rPr>
-              <a:t>Desconfia de discurso verde sem dados</a:t>
-            </a:r>
-            <a:endParaRPr lang="en-US" sz="1600" dirty="0"/>
-          </a:p>
-        </p:txBody>
-      </p:sp>
-      <p:sp>
-        <p:nvSpPr>
-          <p:cNvPr id="6" name="Text 4"/>
-          <p:cNvSpPr txBox="1"/>
-          <p:nvPr/>
-        </p:nvSpPr>
-        <p:spPr>
-          <a:xfrm>
-            <a:off x="822960" y="3794760"/>
-            <a:ext cx="3063240" cy="411480"/>
+              <a:t>Sudeste e Sul, Uruguai, Argentina e Chile</a:t>
+            </a:r>
+            <a:endParaRPr lang="en-US" sz="1400" dirty="0"/>
+          </a:p>
+        </p:txBody>
+      </p:sp>
+      <p:sp>
+        <p:nvSpPr>
+          <p:cNvPr id="7" name="Text 5"/>
+          <p:cNvSpPr txBox="1"/>
+          <p:nvPr/>
+        </p:nvSpPr>
+        <p:spPr>
+          <a:xfrm>
+            <a:off x="3657600" y="1207008"/>
+            <a:ext cx="2423160" cy="237744"/>
           </a:xfrm>
           <a:prstGeom prst="rect">
             <a:avLst/>
@@ -3781,54 +3834,15 @@
               <a:buNone/>
             </a:pPr>
             <a:r>
-              <a:rPr lang="en-US" sz="1400" b="1" dirty="0">
-                <a:solidFill>
-                  <a:schemeClr val="accent2"/>
-                </a:solidFill>
-                <a:latin typeface="Arial" pitchFamily="34" charset="0"/>
-                <a:ea typeface="Arial" pitchFamily="34" charset="-122"/>
-                <a:cs typeface="Arial" pitchFamily="34" charset="-120"/>
-              </a:rPr>
-              <a:t>Premium · R$ 26 a R$ 32 (80 g)</a:t>
-            </a:r>
-            <a:endParaRPr lang="en-US" sz="1400" dirty="0"/>
-          </a:p>
-        </p:txBody>
-      </p:sp>
-      <p:sp>
-        <p:nvSpPr>
-          <p:cNvPr id="7" name="Text 5"/>
-          <p:cNvSpPr txBox="1"/>
-          <p:nvPr/>
-        </p:nvSpPr>
-        <p:spPr>
-          <a:xfrm>
-            <a:off x="4434840" y="1188720"/>
-            <a:ext cx="4206240" cy="237744"/>
-          </a:xfrm>
-          <a:prstGeom prst="rect">
-            <a:avLst/>
-          </a:prstGeom>
-          <a:noFill/>
-          <a:ln/>
-        </p:spPr>
-        <p:txBody>
-          <a:bodyPr wrap="square" lIns="0" tIns="0" rIns="0" bIns="0" rtlCol="0" anchor="t"/>
-          <a:lstStyle/>
-          <a:p>
-            <a:pPr indent="0" marL="0">
-              <a:buNone/>
-            </a:pPr>
-            <a:r>
               <a:rPr lang="en-US" sz="1100" b="1" spc="150" kern="0" dirty="0">
                 <a:solidFill>
-                  <a:schemeClr val="accent1"/>
+                  <a:srgbClr val="5C4A40"/>
                 </a:solidFill>
                 <a:latin typeface="Courier New" pitchFamily="34" charset="0"/>
                 <a:ea typeface="Courier New" pitchFamily="34" charset="-122"/>
                 <a:cs typeface="Courier New" pitchFamily="34" charset="-120"/>
               </a:rPr>
-              <a:t>CONCORRENTES · NOSSO DIFERENCIAL</a:t>
+              <a:t>CONCORRENTES</a:t>
             </a:r>
             <a:endParaRPr lang="en-US" sz="1100" dirty="0"/>
           </a:p>
@@ -3836,14 +3850,53 @@
       </p:sp>
       <p:sp>
         <p:nvSpPr>
-          <p:cNvPr id="8" name="concorrente-1"/>
+          <p:cNvPr id="8" name="Text 6"/>
+          <p:cNvSpPr txBox="1"/>
+          <p:nvPr/>
+        </p:nvSpPr>
+        <p:spPr>
+          <a:xfrm>
+            <a:off x="6217920" y="1207008"/>
+            <a:ext cx="2377440" cy="237744"/>
+          </a:xfrm>
+          <a:prstGeom prst="rect">
+            <a:avLst/>
+          </a:prstGeom>
+          <a:noFill/>
+          <a:ln/>
+        </p:spPr>
+        <p:txBody>
+          <a:bodyPr wrap="square" lIns="0" tIns="0" rIns="0" bIns="0" rtlCol="0" anchor="t"/>
+          <a:lstStyle/>
+          <a:p>
+            <a:pPr indent="0" marL="0">
+              <a:buNone/>
+            </a:pPr>
+            <a:r>
+              <a:rPr lang="en-US" sz="1100" b="1" spc="150" kern="0" dirty="0">
+                <a:solidFill>
+                  <a:srgbClr val="A4492A"/>
+                </a:solidFill>
+                <a:latin typeface="Courier New" pitchFamily="34" charset="0"/>
+                <a:ea typeface="Courier New" pitchFamily="34" charset="-122"/>
+                <a:cs typeface="Courier New" pitchFamily="34" charset="-120"/>
+              </a:rPr>
+              <a:t>NOSSO DIFERENCIAL</a:t>
+            </a:r>
+            <a:endParaRPr lang="en-US" sz="1100" dirty="0"/>
+          </a:p>
+        </p:txBody>
+      </p:sp>
+      <p:sp>
+        <p:nvSpPr>
+          <p:cNvPr id="9" name="concorrente-1"/>
           <p:cNvSpPr/>
           <p:nvPr/>
         </p:nvSpPr>
         <p:spPr>
           <a:xfrm>
-            <a:off x="4434840" y="1554480"/>
-            <a:ext cx="4160520" cy="822960"/>
+            <a:off x="3657600" y="1536192"/>
+            <a:ext cx="2148840" cy="841248"/>
           </a:xfrm>
           <a:prstGeom prst="rect">
             <a:avLst/>
@@ -3868,14 +3921,14 @@
       </p:sp>
       <p:sp>
         <p:nvSpPr>
-          <p:cNvPr id="9" name="Text 7"/>
-          <p:cNvSpPr txBox="1"/>
-          <p:nvPr/>
-        </p:nvSpPr>
-        <p:spPr>
-          <a:xfrm>
-            <a:off x="4617720" y="1664208"/>
-            <a:ext cx="1600200" cy="603504"/>
+          <p:cNvPr id="10" name="Text 8"/>
+          <p:cNvSpPr txBox="1"/>
+          <p:nvPr/>
+        </p:nvSpPr>
+        <p:spPr>
+          <a:xfrm>
+            <a:off x="3822192" y="1536192"/>
+            <a:ext cx="1874520" cy="841248"/>
           </a:xfrm>
           <a:prstGeom prst="rect">
             <a:avLst/>
@@ -3903,28 +3956,6 @@
             </a:r>
             <a:endParaRPr lang="en-US" sz="1600" dirty="0"/>
           </a:p>
-        </p:txBody>
-      </p:sp>
-      <p:sp>
-        <p:nvSpPr>
-          <p:cNvPr id="10" name="Text 8"/>
-          <p:cNvSpPr txBox="1"/>
-          <p:nvPr/>
-        </p:nvSpPr>
-        <p:spPr>
-          <a:xfrm>
-            <a:off x="6263640" y="1664208"/>
-            <a:ext cx="2194560" cy="603504"/>
-          </a:xfrm>
-          <a:prstGeom prst="rect">
-            <a:avLst/>
-          </a:prstGeom>
-          <a:noFill/>
-          <a:ln/>
-        </p:spPr>
-        <p:txBody>
-          <a:bodyPr wrap="square" lIns="0" tIns="0" rIns="0" bIns="0" rtlCol="0" anchor="ctr"/>
-          <a:lstStyle/>
           <a:p>
             <a:pPr indent="0" marL="0">
               <a:buNone/>
@@ -3938,39 +3969,142 @@
                 <a:ea typeface="Arial" pitchFamily="34" charset="-122"/>
                 <a:cs typeface="Arial" pitchFamily="34" charset="-120"/>
               </a:rPr>
-              <a:t>pioneira do bean-to-bar</a:t>
-            </a:r>
-            <a:endParaRPr lang="en-US" sz="1400" dirty="0"/>
-          </a:p>
-          <a:p>
-            <a:pPr indent="0" marL="0">
-              <a:buNone/>
-            </a:pPr>
-            <a:r>
-              <a:rPr lang="en-US" sz="1400" b="1" dirty="0">
-                <a:solidFill>
-                  <a:srgbClr val="A4492A"/>
+              <a:t>Pioneira do bean-to-bar</a:t>
+            </a:r>
+            <a:endParaRPr lang="en-US" sz="1600" dirty="0"/>
+          </a:p>
+        </p:txBody>
+      </p:sp>
+      <p:sp>
+        <p:nvSpPr>
+          <p:cNvPr id="11" name="seta-1"/>
+          <p:cNvSpPr/>
+          <p:nvPr/>
+        </p:nvSpPr>
+        <p:spPr>
+          <a:xfrm>
+            <a:off x="5852160" y="1828800"/>
+            <a:ext cx="274320" cy="256032"/>
+          </a:xfrm>
+          <a:prstGeom prst="rightArrow">
+            <a:avLst/>
+          </a:prstGeom>
+          <a:solidFill>
+            <a:srgbClr val="D6CBBB"/>
+          </a:solidFill>
+          <a:ln w="12700">
+            <a:solidFill>
+              <a:srgbClr val="D6CBBB"/>
+            </a:solidFill>
+            <a:prstDash val="solid"/>
+          </a:ln>
+        </p:spPr>
+      </p:sp>
+      <p:sp>
+        <p:nvSpPr>
+          <p:cNvPr id="12" name="diferencial-1"/>
+          <p:cNvSpPr/>
+          <p:nvPr/>
+        </p:nvSpPr>
+        <p:spPr>
+          <a:xfrm>
+            <a:off x="6217920" y="1536192"/>
+            <a:ext cx="2377440" cy="841248"/>
+          </a:xfrm>
+          <a:prstGeom prst="rect">
+            <a:avLst/>
+          </a:prstGeom>
+          <a:solidFill>
+            <a:srgbClr val="A4492A"/>
+          </a:solidFill>
+          <a:ln w="9525">
+            <a:solidFill>
+              <a:srgbClr val="A4492A"/>
+            </a:solidFill>
+            <a:prstDash val="solid"/>
+          </a:ln>
+          <a:effectLst>
+            <a:outerShdw sx="100000" sy="100000" kx="0" ky="0" algn="bl" rotWithShape="0" blurRad="76200" dist="25400" dir="5400000">
+              <a:srgbClr val="2A1A14">
+                <a:alpha val="12000"/>
+              </a:srgbClr>
+            </a:outerShdw>
+          </a:effectLst>
+        </p:spPr>
+      </p:sp>
+      <p:pic>
+        <p:nvPicPr>
+          <p:cNvPr id="13" name="simbolo-dif-1" descr="E:\FGV\Matéria 1 - Argo\Desafio 2\geradores\figuras\simbolo-polpa.png">    </p:cNvPr>
+          <p:cNvPicPr>
+            <a:picLocks noChangeAspect="1"/>
+          </p:cNvPicPr>
+          <p:nvPr/>
+        </p:nvPicPr>
+        <p:blipFill>
+          <a:blip r:embed="rId1"/>
+          <a:stretch>
+            <a:fillRect/>
+          </a:stretch>
+        </p:blipFill>
+        <p:spPr>
+          <a:xfrm>
+            <a:off x="6382512" y="1773936"/>
+            <a:ext cx="262805" cy="365760"/>
+          </a:xfrm>
+          <a:prstGeom prst="rect">
+            <a:avLst/>
+          </a:prstGeom>
+        </p:spPr>
+      </p:pic>
+      <p:sp>
+        <p:nvSpPr>
+          <p:cNvPr id="14" name="Text 11"/>
+          <p:cNvSpPr txBox="1"/>
+          <p:nvPr/>
+        </p:nvSpPr>
+        <p:spPr>
+          <a:xfrm>
+            <a:off x="6782477" y="1536192"/>
+            <a:ext cx="1611715" cy="841248"/>
+          </a:xfrm>
+          <a:prstGeom prst="rect">
+            <a:avLst/>
+          </a:prstGeom>
+          <a:noFill/>
+          <a:ln/>
+        </p:spPr>
+        <p:txBody>
+          <a:bodyPr wrap="square" lIns="0" tIns="0" rIns="0" bIns="0" rtlCol="0" anchor="ctr"/>
+          <a:lstStyle/>
+          <a:p>
+            <a:pPr indent="0" marL="0">
+              <a:buNone/>
+            </a:pPr>
+            <a:r>
+              <a:rPr lang="en-US" sz="1500" b="1" dirty="0">
+                <a:solidFill>
+                  <a:srgbClr val="FFFFFF"/>
                 </a:solidFill>
                 <a:latin typeface="Arial" pitchFamily="34" charset="0"/>
                 <a:ea typeface="Arial" pitchFamily="34" charset="-122"/>
                 <a:cs typeface="Arial" pitchFamily="34" charset="-120"/>
               </a:rPr>
-              <a:t>produtor comprovado por lote</a:t>
-            </a:r>
-            <a:endParaRPr lang="en-US" sz="1400" dirty="0"/>
-          </a:p>
-        </p:txBody>
-      </p:sp>
-      <p:sp>
-        <p:nvSpPr>
-          <p:cNvPr id="11" name="concorrente-2"/>
+              <a:t>Produtor comprovado por lote</a:t>
+            </a:r>
+            <a:endParaRPr lang="en-US" sz="1500" dirty="0"/>
+          </a:p>
+        </p:txBody>
+      </p:sp>
+      <p:sp>
+        <p:nvSpPr>
+          <p:cNvPr id="15" name="concorrente-2"/>
           <p:cNvSpPr/>
           <p:nvPr/>
         </p:nvSpPr>
         <p:spPr>
           <a:xfrm>
-            <a:off x="4434840" y="2514600"/>
-            <a:ext cx="4160520" cy="822960"/>
+            <a:off x="3657600" y="2542032"/>
+            <a:ext cx="2148840" cy="841248"/>
           </a:xfrm>
           <a:prstGeom prst="rect">
             <a:avLst/>
@@ -3995,14 +4129,14 @@
       </p:sp>
       <p:sp>
         <p:nvSpPr>
-          <p:cNvPr id="12" name="Text 10"/>
-          <p:cNvSpPr txBox="1"/>
-          <p:nvPr/>
-        </p:nvSpPr>
-        <p:spPr>
-          <a:xfrm>
-            <a:off x="4617720" y="2624328"/>
-            <a:ext cx="1600200" cy="603504"/>
+          <p:cNvPr id="16" name="Text 13"/>
+          <p:cNvSpPr txBox="1"/>
+          <p:nvPr/>
+        </p:nvSpPr>
+        <p:spPr>
+          <a:xfrm>
+            <a:off x="3822192" y="2542032"/>
+            <a:ext cx="1874520" cy="841248"/>
           </a:xfrm>
           <a:prstGeom prst="rect">
             <a:avLst/>
@@ -4030,28 +4164,6 @@
             </a:r>
             <a:endParaRPr lang="en-US" sz="1600" dirty="0"/>
           </a:p>
-        </p:txBody>
-      </p:sp>
-      <p:sp>
-        <p:nvSpPr>
-          <p:cNvPr id="13" name="Text 11"/>
-          <p:cNvSpPr txBox="1"/>
-          <p:nvPr/>
-        </p:nvSpPr>
-        <p:spPr>
-          <a:xfrm>
-            <a:off x="6263640" y="2624328"/>
-            <a:ext cx="2194560" cy="603504"/>
-          </a:xfrm>
-          <a:prstGeom prst="rect">
-            <a:avLst/>
-          </a:prstGeom>
-          <a:noFill/>
-          <a:ln/>
-        </p:spPr>
-        <p:txBody>
-          <a:bodyPr wrap="square" lIns="0" tIns="0" rIns="0" bIns="0" rtlCol="0" anchor="ctr"/>
-          <a:lstStyle/>
           <a:p>
             <a:pPr indent="0" marL="0">
               <a:buNone/>
@@ -4065,39 +4177,142 @@
                 <a:ea typeface="Arial" pitchFamily="34" charset="-122"/>
                 <a:cs typeface="Arial" pitchFamily="34" charset="-120"/>
               </a:rPr>
-              <a:t>propósito e origem baiana</a:t>
-            </a:r>
-            <a:endParaRPr lang="en-US" sz="1400" dirty="0"/>
-          </a:p>
-          <a:p>
-            <a:pPr indent="0" marL="0">
-              <a:buNone/>
-            </a:pPr>
-            <a:r>
-              <a:rPr lang="en-US" sz="1400" b="1" dirty="0">
-                <a:solidFill>
-                  <a:srgbClr val="A4492A"/>
+              <a:t>Propósito e origem baiana</a:t>
+            </a:r>
+            <a:endParaRPr lang="en-US" sz="1600" dirty="0"/>
+          </a:p>
+        </p:txBody>
+      </p:sp>
+      <p:sp>
+        <p:nvSpPr>
+          <p:cNvPr id="17" name="seta-2"/>
+          <p:cNvSpPr/>
+          <p:nvPr/>
+        </p:nvSpPr>
+        <p:spPr>
+          <a:xfrm>
+            <a:off x="5852160" y="2834640"/>
+            <a:ext cx="274320" cy="256032"/>
+          </a:xfrm>
+          <a:prstGeom prst="rightArrow">
+            <a:avLst/>
+          </a:prstGeom>
+          <a:solidFill>
+            <a:srgbClr val="D6CBBB"/>
+          </a:solidFill>
+          <a:ln w="12700">
+            <a:solidFill>
+              <a:srgbClr val="D6CBBB"/>
+            </a:solidFill>
+            <a:prstDash val="solid"/>
+          </a:ln>
+        </p:spPr>
+      </p:sp>
+      <p:sp>
+        <p:nvSpPr>
+          <p:cNvPr id="18" name="diferencial-2"/>
+          <p:cNvSpPr/>
+          <p:nvPr/>
+        </p:nvSpPr>
+        <p:spPr>
+          <a:xfrm>
+            <a:off x="6217920" y="2542032"/>
+            <a:ext cx="2377440" cy="841248"/>
+          </a:xfrm>
+          <a:prstGeom prst="rect">
+            <a:avLst/>
+          </a:prstGeom>
+          <a:solidFill>
+            <a:srgbClr val="A4492A"/>
+          </a:solidFill>
+          <a:ln w="9525">
+            <a:solidFill>
+              <a:srgbClr val="A4492A"/>
+            </a:solidFill>
+            <a:prstDash val="solid"/>
+          </a:ln>
+          <a:effectLst>
+            <a:outerShdw sx="100000" sy="100000" kx="0" ky="0" algn="bl" rotWithShape="0" blurRad="76200" dist="25400" dir="5400000">
+              <a:srgbClr val="2A1A14">
+                <a:alpha val="12000"/>
+              </a:srgbClr>
+            </a:outerShdw>
+          </a:effectLst>
+        </p:spPr>
+      </p:sp>
+      <p:pic>
+        <p:nvPicPr>
+          <p:cNvPr id="19" name="simbolo-dif-2" descr="E:\FGV\Matéria 1 - Argo\Desafio 2\geradores\figuras\simbolo-polpa.png">    </p:cNvPr>
+          <p:cNvPicPr>
+            <a:picLocks noChangeAspect="1"/>
+          </p:cNvPicPr>
+          <p:nvPr/>
+        </p:nvPicPr>
+        <p:blipFill>
+          <a:blip r:embed="rId2"/>
+          <a:stretch>
+            <a:fillRect/>
+          </a:stretch>
+        </p:blipFill>
+        <p:spPr>
+          <a:xfrm>
+            <a:off x="6382512" y="2779776"/>
+            <a:ext cx="262805" cy="365760"/>
+          </a:xfrm>
+          <a:prstGeom prst="rect">
+            <a:avLst/>
+          </a:prstGeom>
+        </p:spPr>
+      </p:pic>
+      <p:sp>
+        <p:nvSpPr>
+          <p:cNvPr id="20" name="Text 16"/>
+          <p:cNvSpPr txBox="1"/>
+          <p:nvPr/>
+        </p:nvSpPr>
+        <p:spPr>
+          <a:xfrm>
+            <a:off x="6782477" y="2542032"/>
+            <a:ext cx="1611715" cy="841248"/>
+          </a:xfrm>
+          <a:prstGeom prst="rect">
+            <a:avLst/>
+          </a:prstGeom>
+          <a:noFill/>
+          <a:ln/>
+        </p:spPr>
+        <p:txBody>
+          <a:bodyPr wrap="square" lIns="0" tIns="0" rIns="0" bIns="0" rtlCol="0" anchor="ctr"/>
+          <a:lstStyle/>
+          <a:p>
+            <a:pPr indent="0" marL="0">
+              <a:buNone/>
+            </a:pPr>
+            <a:r>
+              <a:rPr lang="en-US" sz="1500" b="1" dirty="0">
+                <a:solidFill>
+                  <a:srgbClr val="FFFFFF"/>
                 </a:solidFill>
                 <a:latin typeface="Arial" pitchFamily="34" charset="0"/>
                 <a:ea typeface="Arial" pitchFamily="34" charset="-122"/>
                 <a:cs typeface="Arial" pitchFamily="34" charset="-120"/>
               </a:rPr>
-              <a:t>lote rastreável e valor pago publicado</a:t>
-            </a:r>
-            <a:endParaRPr lang="en-US" sz="1400" dirty="0"/>
-          </a:p>
-        </p:txBody>
-      </p:sp>
-      <p:sp>
-        <p:nvSpPr>
-          <p:cNvPr id="14" name="concorrente-3"/>
+              <a:t>Lote rastreável e valor pago publicado</a:t>
+            </a:r>
+            <a:endParaRPr lang="en-US" sz="1500" dirty="0"/>
+          </a:p>
+        </p:txBody>
+      </p:sp>
+      <p:sp>
+        <p:nvSpPr>
+          <p:cNvPr id="21" name="concorrente-3"/>
           <p:cNvSpPr/>
           <p:nvPr/>
         </p:nvSpPr>
         <p:spPr>
           <a:xfrm>
-            <a:off x="4434840" y="3474720"/>
-            <a:ext cx="4160520" cy="822960"/>
+            <a:off x="3657600" y="3547872"/>
+            <a:ext cx="2148840" cy="841248"/>
           </a:xfrm>
           <a:prstGeom prst="rect">
             <a:avLst/>
@@ -4122,14 +4337,14 @@
       </p:sp>
       <p:sp>
         <p:nvSpPr>
-          <p:cNvPr id="15" name="Text 13"/>
-          <p:cNvSpPr txBox="1"/>
-          <p:nvPr/>
-        </p:nvSpPr>
-        <p:spPr>
-          <a:xfrm>
-            <a:off x="4617720" y="3584448"/>
-            <a:ext cx="1600200" cy="603504"/>
+          <p:cNvPr id="22" name="Text 18"/>
+          <p:cNvSpPr txBox="1"/>
+          <p:nvPr/>
+        </p:nvSpPr>
+        <p:spPr>
+          <a:xfrm>
+            <a:off x="3822192" y="3547872"/>
+            <a:ext cx="1874520" cy="841248"/>
           </a:xfrm>
           <a:prstGeom prst="rect">
             <a:avLst/>
@@ -4157,28 +4372,6 @@
             </a:r>
             <a:endParaRPr lang="en-US" sz="1600" dirty="0"/>
           </a:p>
-        </p:txBody>
-      </p:sp>
-      <p:sp>
-        <p:nvSpPr>
-          <p:cNvPr id="16" name="Text 14"/>
-          <p:cNvSpPr txBox="1"/>
-          <p:nvPr/>
-        </p:nvSpPr>
-        <p:spPr>
-          <a:xfrm>
-            <a:off x="6263640" y="3584448"/>
-            <a:ext cx="2194560" cy="603504"/>
-          </a:xfrm>
-          <a:prstGeom prst="rect">
-            <a:avLst/>
-          </a:prstGeom>
-          <a:noFill/>
-          <a:ln/>
-        </p:spPr>
-        <p:txBody>
-          <a:bodyPr wrap="square" lIns="0" tIns="0" rIns="0" bIns="0" rtlCol="0" anchor="ctr"/>
-          <a:lstStyle/>
           <a:p>
             <a:pPr indent="0" marL="0">
               <a:buNone/>
@@ -4192,26 +4385,129 @@
                 <a:ea typeface="Arial" pitchFamily="34" charset="-122"/>
                 <a:cs typeface="Arial" pitchFamily="34" charset="-120"/>
               </a:rPr>
-              <a:t>orgânica e agroflorestal</a:t>
-            </a:r>
-            <a:endParaRPr lang="en-US" sz="1400" dirty="0"/>
-          </a:p>
-          <a:p>
-            <a:pPr indent="0" marL="0">
-              <a:buNone/>
-            </a:pPr>
-            <a:r>
-              <a:rPr lang="en-US" sz="1400" b="1" dirty="0">
-                <a:solidFill>
-                  <a:srgbClr val="A4492A"/>
+              <a:t>Orgânica e agroflorestal</a:t>
+            </a:r>
+            <a:endParaRPr lang="en-US" sz="1600" dirty="0"/>
+          </a:p>
+        </p:txBody>
+      </p:sp>
+      <p:sp>
+        <p:nvSpPr>
+          <p:cNvPr id="23" name="seta-3"/>
+          <p:cNvSpPr/>
+          <p:nvPr/>
+        </p:nvSpPr>
+        <p:spPr>
+          <a:xfrm>
+            <a:off x="5852160" y="3840480"/>
+            <a:ext cx="274320" cy="256032"/>
+          </a:xfrm>
+          <a:prstGeom prst="rightArrow">
+            <a:avLst/>
+          </a:prstGeom>
+          <a:solidFill>
+            <a:srgbClr val="D6CBBB"/>
+          </a:solidFill>
+          <a:ln w="12700">
+            <a:solidFill>
+              <a:srgbClr val="D6CBBB"/>
+            </a:solidFill>
+            <a:prstDash val="solid"/>
+          </a:ln>
+        </p:spPr>
+      </p:sp>
+      <p:sp>
+        <p:nvSpPr>
+          <p:cNvPr id="24" name="diferencial-3"/>
+          <p:cNvSpPr/>
+          <p:nvPr/>
+        </p:nvSpPr>
+        <p:spPr>
+          <a:xfrm>
+            <a:off x="6217920" y="3547872"/>
+            <a:ext cx="2377440" cy="841248"/>
+          </a:xfrm>
+          <a:prstGeom prst="rect">
+            <a:avLst/>
+          </a:prstGeom>
+          <a:solidFill>
+            <a:srgbClr val="A4492A"/>
+          </a:solidFill>
+          <a:ln w="9525">
+            <a:solidFill>
+              <a:srgbClr val="A4492A"/>
+            </a:solidFill>
+            <a:prstDash val="solid"/>
+          </a:ln>
+          <a:effectLst>
+            <a:outerShdw sx="100000" sy="100000" kx="0" ky="0" algn="bl" rotWithShape="0" blurRad="76200" dist="25400" dir="5400000">
+              <a:srgbClr val="2A1A14">
+                <a:alpha val="12000"/>
+              </a:srgbClr>
+            </a:outerShdw>
+          </a:effectLst>
+        </p:spPr>
+      </p:sp>
+      <p:pic>
+        <p:nvPicPr>
+          <p:cNvPr id="25" name="simbolo-dif-3" descr="E:\FGV\Matéria 1 - Argo\Desafio 2\geradores\figuras\simbolo-polpa.png">    </p:cNvPr>
+          <p:cNvPicPr>
+            <a:picLocks noChangeAspect="1"/>
+          </p:cNvPicPr>
+          <p:nvPr/>
+        </p:nvPicPr>
+        <p:blipFill>
+          <a:blip r:embed="rId3"/>
+          <a:stretch>
+            <a:fillRect/>
+          </a:stretch>
+        </p:blipFill>
+        <p:spPr>
+          <a:xfrm>
+            <a:off x="6382512" y="3785616"/>
+            <a:ext cx="262805" cy="365760"/>
+          </a:xfrm>
+          <a:prstGeom prst="rect">
+            <a:avLst/>
+          </a:prstGeom>
+        </p:spPr>
+      </p:pic>
+      <p:sp>
+        <p:nvSpPr>
+          <p:cNvPr id="26" name="Text 21"/>
+          <p:cNvSpPr txBox="1"/>
+          <p:nvPr/>
+        </p:nvSpPr>
+        <p:spPr>
+          <a:xfrm>
+            <a:off x="6782477" y="3547872"/>
+            <a:ext cx="1611715" cy="841248"/>
+          </a:xfrm>
+          <a:prstGeom prst="rect">
+            <a:avLst/>
+          </a:prstGeom>
+          <a:noFill/>
+          <a:ln/>
+        </p:spPr>
+        <p:txBody>
+          <a:bodyPr wrap="square" lIns="0" tIns="0" rIns="0" bIns="0" rtlCol="0" anchor="ctr"/>
+          <a:lstStyle/>
+          <a:p>
+            <a:pPr indent="0" marL="0">
+              <a:buNone/>
+            </a:pPr>
+            <a:r>
+              <a:rPr lang="en-US" sz="1500" b="1" dirty="0">
+                <a:solidFill>
+                  <a:srgbClr val="FFFFFF"/>
                 </a:solidFill>
                 <a:latin typeface="Arial" pitchFamily="34" charset="0"/>
                 <a:ea typeface="Arial" pitchFamily="34" charset="-122"/>
                 <a:cs typeface="Arial" pitchFamily="34" charset="-120"/>
               </a:rPr>
-              <a:t>renda publicada por família</a:t>
-            </a:r>
-            <a:endParaRPr lang="en-US" sz="1400" dirty="0"/>
+              <a:t>Renda publicada por família</a:t>
+            </a:r>
+            <a:endParaRPr lang="en-US" sz="1500" dirty="0"/>
           </a:p>
         </p:txBody>
       </p:sp>

</xml_diff>